<commit_message>
feat: restyle example showcase + give each example a distinct brand
Showcase (per design feedback):
- arrows now flank the preview frame (vertically centred, right beside it)
- removed the report name/domain line, the metadata/description bar, and ALL
  download buttons — just browse and scroll the slides, like the reference
- page dots sit below the frame; the frame fills its column

Visual diversity:
- each example report is rendered with its own brand identity (accent + ink +
  fonts) — retail blue/Georgia, FP&A teal/Cambria, SaaS violet/Trebuchet,
  marketing orange/Verdana — demonstrating the same engine producing
  differently-branded decks (exactly what uploading a brand template does)
- build_examples now saves report.json per example and supports REUSE_EXAMPLES=1
  to re-render styling without another LLM call

Co-Authored-By: Claude Fable 5 <noreply@anthropic.com>
</commit_message>
<xml_diff>
--- a/app/examples/fpa_budget/report.pptx
+++ b/app/examples/fpa_budget/report.pptx
@@ -3117,11 +3117,11 @@
             <a:r>
               <a:rPr sz="4600" b="1">
                 <a:solidFill>
-                  <a:srgbClr val="1F2A44"/>
-                </a:solidFill>
-                <a:latin typeface="Georgia"/>
+                  <a:srgbClr val="0C2E27"/>
+                </a:solidFill>
+                <a:latin typeface="Cambria"/>
               </a:rPr>
-              <a:t>May Financial Performance Overview</a:t>
+              <a:t>May Financial Performance Analysis</a:t>
             </a:r>
           </a:p>
         </p:txBody>
@@ -3153,7 +3153,7 @@
                 <a:solidFill>
                   <a:srgbClr val="7A828C"/>
                 </a:solidFill>
-                <a:latin typeface="Arial"/>
+                <a:latin typeface="Calibri"/>
               </a:rPr>
               <a:t>Period 2026-05  |  source table: ex_fpa_budget</a:t>
             </a:r>
@@ -3187,9 +3187,9 @@
                 <a:solidFill>
                   <a:srgbClr val="7A828C"/>
                 </a:solidFill>
-                <a:latin typeface="Arial"/>
+                <a:latin typeface="Calibri"/>
               </a:rPr>
-              <a:t>Generated 2026-06-10 15:44 UTC   |   CONFIDENTIAL</a:t>
+              <a:t>Generated 2026-06-10 17:37 UTC   |   CONFIDENTIAL</a:t>
             </a:r>
           </a:p>
         </p:txBody>
@@ -3237,9 +3237,9 @@
             <a:r>
               <a:rPr sz="1300" b="1">
                 <a:solidFill>
-                  <a:srgbClr val="2E6DB4"/>
-                </a:solidFill>
-                <a:latin typeface="Arial"/>
+                  <a:srgbClr val="0E7C66"/>
+                </a:solidFill>
+                <a:latin typeface="Calibri"/>
               </a:rPr>
               <a:t>EXECUTIVE SUMMARY</a:t>
             </a:r>
@@ -3271,11 +3271,11 @@
             <a:r>
               <a:rPr sz="3000" b="1">
                 <a:solidFill>
-                  <a:srgbClr val="1F2A44"/>
-                </a:solidFill>
-                <a:latin typeface="Georgia"/>
+                  <a:srgbClr val="0C2E27"/>
+                </a:solidFill>
+                <a:latin typeface="Cambria"/>
               </a:rPr>
-              <a:t>Sales remains strong, but Operations faces decline.</a:t>
+              <a:t>Sales remains a strong contributor despite overall decline.</a:t>
             </a:r>
           </a:p>
         </p:txBody>
@@ -3307,7 +3307,7 @@
                 <a:solidFill>
                   <a:srgbClr val="7A828C"/>
                 </a:solidFill>
-                <a:latin typeface="Arial"/>
+                <a:latin typeface="Calibri"/>
               </a:rPr>
               <a:t>Source: figures verified against the source data.</a:t>
             </a:r>
@@ -3344,7 +3344,7 @@
             <a:r>
               <a:rPr sz="1600" b="1">
                 <a:solidFill>
-                  <a:srgbClr val="2E6DB4"/>
+                  <a:srgbClr val="0E7C66"/>
                 </a:solidFill>
               </a:rPr>
               <a:t>●  </a:t>
@@ -3354,9 +3354,9 @@
                 <a:solidFill>
                   <a:srgbClr val="3C4450"/>
                 </a:solidFill>
-                <a:latin typeface="Arial"/>
+                <a:latin typeface="Calibri"/>
               </a:rPr>
-              <a:t>Total actual is $501k in 2026-05, down from $511k in 2026-04.</a:t>
+              <a:t>Total actual is $501k in 2026-05, reflecting a decline of -1.9%.</a:t>
             </a:r>
           </a:p>
           <a:p>
@@ -3368,7 +3368,7 @@
             <a:r>
               <a:rPr sz="1600" b="1">
                 <a:solidFill>
-                  <a:srgbClr val="2E6DB4"/>
+                  <a:srgbClr val="0E7C66"/>
                 </a:solidFill>
               </a:rPr>
               <a:t>●  </a:t>
@@ -3378,7 +3378,7 @@
                 <a:solidFill>
                   <a:srgbClr val="3C4450"/>
                 </a:solidFill>
-                <a:latin typeface="Arial"/>
+                <a:latin typeface="Calibri"/>
               </a:rPr>
               <a:t>Sales leads with $147k, representing 29.3% of total actual.</a:t>
             </a:r>
@@ -3392,7 +3392,7 @@
             <a:r>
               <a:rPr sz="1600" b="1">
                 <a:solidFill>
-                  <a:srgbClr val="2E6DB4"/>
+                  <a:srgbClr val="0E7C66"/>
                 </a:solidFill>
               </a:rPr>
               <a:t>●  </a:t>
@@ -3402,9 +3402,9 @@
                 <a:solidFill>
                   <a:srgbClr val="3C4450"/>
                 </a:solidFill>
-                <a:latin typeface="Arial"/>
+                <a:latin typeface="Calibri"/>
               </a:rPr>
-              <a:t>Operations experienced the largest decline at -$8k compared to prior.</a:t>
+              <a:t>Operations experienced the largest decline at -$8k compared to prior month.</a:t>
             </a:r>
           </a:p>
         </p:txBody>
@@ -3452,9 +3452,9 @@
             <a:r>
               <a:rPr sz="1300" b="1">
                 <a:solidFill>
-                  <a:srgbClr val="2E6DB4"/>
-                </a:solidFill>
-                <a:latin typeface="Arial"/>
+                  <a:srgbClr val="0E7C66"/>
+                </a:solidFill>
+                <a:latin typeface="Calibri"/>
               </a:rPr>
               <a:t>FINANCIAL PERFORMANCE</a:t>
             </a:r>
@@ -3486,11 +3486,11 @@
             <a:r>
               <a:rPr sz="3000" b="1">
                 <a:solidFill>
-                  <a:srgbClr val="1F2A44"/>
-                </a:solidFill>
-                <a:latin typeface="Georgia"/>
+                  <a:srgbClr val="0C2E27"/>
+                </a:solidFill>
+                <a:latin typeface="Cambria"/>
               </a:rPr>
-              <a:t>Actual declined to $501k in May, down $10k from April's peak of $511k.</a:t>
+              <a:t>Actual decreased to $501k in May, down $10k from April's peak of $511k.</a:t>
             </a:r>
           </a:p>
         </p:txBody>
@@ -3522,7 +3522,7 @@
                 <a:solidFill>
                   <a:srgbClr val="7A828C"/>
                 </a:solidFill>
-                <a:latin typeface="Arial"/>
+                <a:latin typeface="Calibri"/>
               </a:rPr>
               <a:t>Source: performance: Monthly actual, verified against the data.</a:t>
             </a:r>
@@ -3580,9 +3580,9 @@
                 <a:solidFill>
                   <a:srgbClr val="7A828C"/>
                 </a:solidFill>
-                <a:latin typeface="Arial"/>
+                <a:latin typeface="Calibri"/>
               </a:rPr>
-              <a:t>In May 2026, actual totaled $501k, reflecting a decrease of $10k or -1.9% compared to April's peak of $511k. This decline follows a recent upward trend, with April marking the highest monthly actual in the past year. Historically, actual has shown seasonal fluctuations, with the highest figures typically occurring in the early months of the year.</a:t>
+              <a:t>In May 2026, actual totaled $501k, reflecting a decrease of $10k or -1.9% compared to April's peak of $511k. This decline marks a slight dip following a strong performance in April, which was the highest month recorded in the past year. The trend over the last 12 months shows fluctuations, with the highest monthly actual consistently around $511k.</a:t>
             </a:r>
           </a:p>
         </p:txBody>
@@ -3602,7 +3602,7 @@
             <a:avLst/>
           </a:prstGeom>
           <a:solidFill>
-            <a:srgbClr val="1F2A44"/>
+            <a:srgbClr val="0C2E27"/>
           </a:solidFill>
           <a:ln>
             <a:noFill/>
@@ -3633,7 +3633,7 @@
                 <a:solidFill>
                   <a:srgbClr val="FFFFFF"/>
                 </a:solidFill>
-                <a:latin typeface="Arial"/>
+                <a:latin typeface="Calibri"/>
               </a:rPr>
               <a:t>KEY TAKEAWAY</a:t>
             </a:r>
@@ -3692,9 +3692,9 @@
                 <a:solidFill>
                   <a:srgbClr val="3C4450"/>
                 </a:solidFill>
-                <a:latin typeface="Arial"/>
+                <a:latin typeface="Calibri"/>
               </a:rPr>
-              <a:t>The decline in May suggests a need to analyze factors affecting monthly performance.</a:t>
+              <a:t>Maintaining focus on sustaining performance is crucial as we navigate post-peak adjustments.</a:t>
             </a:r>
           </a:p>
           <a:p>
@@ -3708,9 +3708,9 @@
                 <a:solidFill>
                   <a:srgbClr val="3C4450"/>
                 </a:solidFill>
-                <a:latin typeface="Arial"/>
+                <a:latin typeface="Calibri"/>
               </a:rPr>
-              <a:t>•  May's actual of $501k is lower than April's $511k peak.</a:t>
+              <a:t>•  May's actual of $501k is below April's peak of $511k.</a:t>
             </a:r>
           </a:p>
           <a:p>
@@ -3724,9 +3724,9 @@
                 <a:solidFill>
                   <a:srgbClr val="3C4450"/>
                 </a:solidFill>
-                <a:latin typeface="Arial"/>
+                <a:latin typeface="Calibri"/>
               </a:rPr>
-              <a:t>•  The trend shows a recent peak in April, followed by a slight decline.</a:t>
+              <a:t>•  The last 12 months show a peak in April 2026.</a:t>
             </a:r>
           </a:p>
           <a:p>
@@ -3740,9 +3740,9 @@
                 <a:solidFill>
                   <a:srgbClr val="3C4450"/>
                 </a:solidFill>
-                <a:latin typeface="Arial"/>
+                <a:latin typeface="Calibri"/>
               </a:rPr>
-              <a:t>•  Year-over-year, actual remains strong compared to mid-2025 levels around $484k.</a:t>
+              <a:t>•  Monthly actuals have fluctuated between $463k and $511k.</a:t>
             </a:r>
           </a:p>
         </p:txBody>
@@ -3790,9 +3790,9 @@
             <a:r>
               <a:rPr sz="1300" b="1">
                 <a:solidFill>
-                  <a:srgbClr val="2E6DB4"/>
-                </a:solidFill>
-                <a:latin typeface="Arial"/>
+                  <a:srgbClr val="0E7C66"/>
+                </a:solidFill>
+                <a:latin typeface="Calibri"/>
               </a:rPr>
               <a:t>DEPARTMENT BREAKDOWN</a:t>
             </a:r>
@@ -3824,11 +3824,11 @@
             <a:r>
               <a:rPr sz="3000" b="1">
                 <a:solidFill>
-                  <a:srgbClr val="1F2A44"/>
-                </a:solidFill>
-                <a:latin typeface="Georgia"/>
+                  <a:srgbClr val="0C2E27"/>
+                </a:solidFill>
+                <a:latin typeface="Cambria"/>
               </a:rPr>
-              <a:t>Operations leads with $101k, but decreased by -$8k from April.</a:t>
+              <a:t>Operations leads with $101k, but decreased by -$8k from last month.</a:t>
             </a:r>
           </a:p>
         </p:txBody>
@@ -3860,7 +3860,7 @@
                 <a:solidFill>
                   <a:srgbClr val="7A828C"/>
                 </a:solidFill>
-                <a:latin typeface="Arial"/>
+                <a:latin typeface="Calibri"/>
               </a:rPr>
               <a:t>Source: dim_department: actual by department (2026-05), verified against the data.</a:t>
             </a:r>
@@ -3918,9 +3918,9 @@
                 <a:solidFill>
                   <a:srgbClr val="7A828C"/>
                 </a:solidFill>
-                <a:latin typeface="Arial"/>
+                <a:latin typeface="Calibri"/>
               </a:rPr>
-              <a:t>In May 2026, Operations holds the highest total at $101k, despite a decline of -$8k compared to April. Sales follows closely with $147k, also experiencing a slight decrease of -$1k. Marketing is the only department that saw an increase, rising by +$2k to reach $75k, indicating a positive trend in that area.</a:t>
+              <a:t>In May 2026, Operations is the leading department with an actual total of $101k, despite experiencing a decline of -$8k compared to April 2026. Sales follows closely with $147k, while Marketing shows a positive trend with an increase of +$2k, reaching $75k. The overall concentration of spending highlights a significant focus on Sales and Operations, which together account for a substantial portion of the total departmental spend.</a:t>
             </a:r>
           </a:p>
         </p:txBody>
@@ -3940,7 +3940,7 @@
             <a:avLst/>
           </a:prstGeom>
           <a:solidFill>
-            <a:srgbClr val="1F2A44"/>
+            <a:srgbClr val="0C2E27"/>
           </a:solidFill>
           <a:ln>
             <a:noFill/>
@@ -3971,7 +3971,7 @@
                 <a:solidFill>
                   <a:srgbClr val="FFFFFF"/>
                 </a:solidFill>
-                <a:latin typeface="Arial"/>
+                <a:latin typeface="Calibri"/>
               </a:rPr>
               <a:t>KEY TAKEAWAY</a:t>
             </a:r>
@@ -4030,9 +4030,9 @@
                 <a:solidFill>
                   <a:srgbClr val="3C4450"/>
                 </a:solidFill>
-                <a:latin typeface="Arial"/>
+                <a:latin typeface="Calibri"/>
               </a:rPr>
-              <a:t>Focus on revitalizing Operations and leveraging Marketing's growth to enhance overall performance.</a:t>
+              <a:t>The decline in Operations spending signals potential operational challenges that need addressing.</a:t>
             </a:r>
           </a:p>
           <a:p>
@@ -4046,9 +4046,9 @@
                 <a:solidFill>
                   <a:srgbClr val="3C4450"/>
                 </a:solidFill>
-                <a:latin typeface="Arial"/>
+                <a:latin typeface="Calibri"/>
               </a:rPr>
-              <a:t>•  Operations decreased by -$8k, leading the department totals at $101k.</a:t>
+              <a:t>•  Sales at $147k remains the highest department spend.</a:t>
             </a:r>
           </a:p>
           <a:p>
@@ -4062,9 +4062,9 @@
                 <a:solidFill>
                   <a:srgbClr val="3C4450"/>
                 </a:solidFill>
-                <a:latin typeface="Arial"/>
+                <a:latin typeface="Calibri"/>
               </a:rPr>
-              <a:t>•  Sales remains significant at $147k, but declined by -$1k.</a:t>
+              <a:t>•  Operations saw the largest decrease of -$8k this month.</a:t>
             </a:r>
           </a:p>
           <a:p>
@@ -4078,9 +4078,9 @@
                 <a:solidFill>
                   <a:srgbClr val="3C4450"/>
                 </a:solidFill>
-                <a:latin typeface="Arial"/>
+                <a:latin typeface="Calibri"/>
               </a:rPr>
-              <a:t>•  Marketing increased by +$2k, showing growth in its budget allocation.</a:t>
+              <a:t>•  Marketing is the only department with a positive change, increasing by +$2k.</a:t>
             </a:r>
           </a:p>
         </p:txBody>
@@ -4128,9 +4128,9 @@
             <a:r>
               <a:rPr sz="1300" b="1">
                 <a:solidFill>
-                  <a:srgbClr val="2E6DB4"/>
-                </a:solidFill>
-                <a:latin typeface="Arial"/>
+                  <a:srgbClr val="0E7C66"/>
+                </a:solidFill>
+                <a:latin typeface="Calibri"/>
               </a:rPr>
               <a:t>RECOMMENDATIONS</a:t>
             </a:r>
@@ -4162,9 +4162,9 @@
             <a:r>
               <a:rPr sz="3000" b="1">
                 <a:solidFill>
-                  <a:srgbClr val="1F2A44"/>
-                </a:solidFill>
-                <a:latin typeface="Georgia"/>
+                  <a:srgbClr val="0C2E27"/>
+                </a:solidFill>
+                <a:latin typeface="Cambria"/>
               </a:rPr>
               <a:t>Priorities for the coming month</a:t>
             </a:r>
@@ -4198,7 +4198,7 @@
                 <a:solidFill>
                   <a:srgbClr val="7A828C"/>
                 </a:solidFill>
-                <a:latin typeface="Arial"/>
+                <a:latin typeface="Calibri"/>
               </a:rPr>
               <a:t>Source: figures verified against the source data.</a:t>
             </a:r>
@@ -4237,9 +4237,9 @@
                 <a:solidFill>
                   <a:srgbClr val="3C4450"/>
                 </a:solidFill>
-                <a:latin typeface="Arial"/>
+                <a:latin typeface="Calibri"/>
               </a:rPr>
-              <a:t>1.   Increase Sales initiatives to capitalize on the $147k contribution, which is 29.3% of total.</a:t>
+              <a:t>1.   Increase Sales initiatives to capitalize on $147k contribution, representing 29.3% of total actual.</a:t>
             </a:r>
           </a:p>
           <a:p>
@@ -4253,9 +4253,9 @@
                 <a:solidFill>
                   <a:srgbClr val="3C4450"/>
                 </a:solidFill>
-                <a:latin typeface="Arial"/>
+                <a:latin typeface="Calibri"/>
               </a:rPr>
-              <a:t>2.   Investigate the $8k decline in Operations to identify root causes and implement corrective actions.</a:t>
+              <a:t>2.   Investigate Operations' decline of -$8k to identify root causes and implement corrective actions.</a:t>
             </a:r>
           </a:p>
           <a:p>
@@ -4269,9 +4269,9 @@
                 <a:solidFill>
                   <a:srgbClr val="3C4450"/>
                 </a:solidFill>
-                <a:latin typeface="Arial"/>
+                <a:latin typeface="Calibri"/>
               </a:rPr>
-              <a:t>3.   Review budget allocations to ensure support for departments experiencing declines, particularly Operations.</a:t>
+              <a:t>3.   Reassess budget allocations to prioritize departments with positive performance trends and mitigate declines.</a:t>
             </a:r>
           </a:p>
           <a:p>
@@ -4285,9 +4285,9 @@
                 <a:solidFill>
                   <a:srgbClr val="3C4450"/>
                 </a:solidFill>
-                <a:latin typeface="Arial"/>
+                <a:latin typeface="Calibri"/>
               </a:rPr>
-              <a:t>4.   Enhance performance tracking to address the overall actual decrease of $10k from the prior month.</a:t>
+              <a:t>4.   Enhance cross-department collaboration to leverage Sales strategies in Operations for improved performance.</a:t>
             </a:r>
           </a:p>
         </p:txBody>

</xml_diff>

<commit_message>
feat: MBB-grade deck variety — dark cover, KPI layout, cleaner showcase
Renderer (benefits every generated report, not just the examples):
- striking full-bleed dark cover slide (brand-ink background, accent rule, large
  white title); dropped the "Generated ... | CONFIDENTIAL" line
- second insight layout: title -> centred chart -> a row of three KPI cards
  (big number + label, drawn from the chart data); alternates with the classic
  chart-left / takeaway-right layout so the deck varies slide to slide

Examples:
- marketing retheme away from orange/brown -> refined burgundy + Tahoma
- clean cover subtitle (no internal table name)

Showcase UI:
- preview now renders in an iframe: no app-like 3-dot banner (reads as a finished
  deck), and switching reports starts a fresh frame scrolled to the top
- larger arrow glyphs in the nav circles

Re-rendered the four example decks from cached report.json (no LLM calls).

Co-Authored-By: Claude Fable 5 <noreply@anthropic.com>
</commit_message>
<xml_diff>
--- a/app/examples/fpa_budget/report.pptx
+++ b/app/examples/fpa_budget/report.pptx
@@ -3094,14 +3094,58 @@
       <p:grpSpPr/>
       <p:sp>
         <p:nvSpPr>
-          <p:cNvPr id="2" name="TextBox 1"/>
+          <p:cNvPr id="2" name="Rectangle 1"/>
+          <p:cNvSpPr/>
+          <p:nvPr/>
+        </p:nvSpPr>
+        <p:spPr>
+          <a:xfrm>
+            <a:off x="0" y="0"/>
+            <a:ext cx="12191695" cy="6858000"/>
+          </a:xfrm>
+          <a:prstGeom prst="rect">
+            <a:avLst/>
+          </a:prstGeom>
+          <a:solidFill>
+            <a:srgbClr val="0C2E27"/>
+          </a:solidFill>
+          <a:ln>
+            <a:noFill/>
+          </a:ln>
+          <a:effectLst/>
+        </p:spPr>
+        <p:style>
+          <a:lnRef idx="1">
+            <a:schemeClr val="accent1"/>
+          </a:lnRef>
+          <a:fillRef idx="3">
+            <a:schemeClr val="accent1"/>
+          </a:fillRef>
+          <a:effectRef idx="2">
+            <a:schemeClr val="accent1"/>
+          </a:effectRef>
+          <a:fontRef idx="minor">
+            <a:schemeClr val="lt1"/>
+          </a:fontRef>
+        </p:style>
+        <p:txBody>
+          <a:bodyPr rtlCol="0" anchor="ctr"/>
+          <a:lstStyle/>
+          <a:p>
+            <a:pPr algn="ctr"/>
+          </a:p>
+        </p:txBody>
+      </p:sp>
+      <p:sp>
+        <p:nvSpPr>
+          <p:cNvPr id="3" name="TextBox 2"/>
           <p:cNvSpPr txBox="1"/>
           <p:nvPr/>
         </p:nvSpPr>
         <p:spPr>
           <a:xfrm>
-            <a:off x="640080" y="2057400"/>
-            <a:ext cx="10881360" cy="1554480"/>
+            <a:off x="777240" y="2148840"/>
+            <a:ext cx="10607040" cy="365760"/>
           </a:xfrm>
           <a:prstGeom prst="rect">
             <a:avLst/>
@@ -3115,27 +3159,71 @@
           <a:lstStyle/>
           <a:p>
             <a:r>
-              <a:rPr sz="4600" b="1">
-                <a:solidFill>
-                  <a:srgbClr val="0C2E27"/>
-                </a:solidFill>
-                <a:latin typeface="Cambria"/>
+              <a:rPr sz="1400" b="1">
+                <a:solidFill>
+                  <a:srgbClr val="0E7C66"/>
+                </a:solidFill>
+                <a:latin typeface="Calibri"/>
               </a:rPr>
-              <a:t>May Financial Performance Analysis</a:t>
-            </a:r>
-          </a:p>
-        </p:txBody>
-      </p:sp>
-      <p:sp>
-        <p:nvSpPr>
-          <p:cNvPr id="3" name="TextBox 2"/>
+              <a:t>PERFORMANCE REVIEW  ·  2026-05</a:t>
+            </a:r>
+          </a:p>
+        </p:txBody>
+      </p:sp>
+      <p:sp>
+        <p:nvSpPr>
+          <p:cNvPr id="4" name="Rectangle 3"/>
+          <p:cNvSpPr/>
+          <p:nvPr/>
+        </p:nvSpPr>
+        <p:spPr>
+          <a:xfrm>
+            <a:off x="822960" y="2697480"/>
+            <a:ext cx="1554480" cy="76200"/>
+          </a:xfrm>
+          <a:prstGeom prst="rect">
+            <a:avLst/>
+          </a:prstGeom>
+          <a:solidFill>
+            <a:srgbClr val="0E7C66"/>
+          </a:solidFill>
+          <a:ln>
+            <a:noFill/>
+          </a:ln>
+          <a:effectLst/>
+        </p:spPr>
+        <p:style>
+          <a:lnRef idx="1">
+            <a:schemeClr val="accent1"/>
+          </a:lnRef>
+          <a:fillRef idx="3">
+            <a:schemeClr val="accent1"/>
+          </a:fillRef>
+          <a:effectRef idx="2">
+            <a:schemeClr val="accent1"/>
+          </a:effectRef>
+          <a:fontRef idx="minor">
+            <a:schemeClr val="lt1"/>
+          </a:fontRef>
+        </p:style>
+        <p:txBody>
+          <a:bodyPr rtlCol="0" anchor="ctr"/>
+          <a:lstStyle/>
+          <a:p>
+            <a:pPr algn="ctr"/>
+          </a:p>
+        </p:txBody>
+      </p:sp>
+      <p:sp>
+        <p:nvSpPr>
+          <p:cNvPr id="5" name="TextBox 4"/>
           <p:cNvSpPr txBox="1"/>
           <p:nvPr/>
         </p:nvSpPr>
         <p:spPr>
           <a:xfrm>
-            <a:off x="640080" y="3703320"/>
-            <a:ext cx="10881360" cy="548640"/>
+            <a:off x="731520" y="2926080"/>
+            <a:ext cx="10698480" cy="1828800"/>
           </a:xfrm>
           <a:prstGeom prst="rect">
             <a:avLst/>
@@ -3149,27 +3237,27 @@
           <a:lstStyle/>
           <a:p>
             <a:r>
-              <a:rPr sz="1700" b="0">
-                <a:solidFill>
-                  <a:srgbClr val="7A828C"/>
-                </a:solidFill>
-                <a:latin typeface="Calibri"/>
+              <a:rPr sz="4600" b="1">
+                <a:solidFill>
+                  <a:srgbClr val="FFFFFF"/>
+                </a:solidFill>
+                <a:latin typeface="Cambria"/>
               </a:rPr>
-              <a:t>Period 2026-05  |  source table: ex_fpa_budget</a:t>
-            </a:r>
-          </a:p>
-        </p:txBody>
-      </p:sp>
-      <p:sp>
-        <p:nvSpPr>
-          <p:cNvPr id="4" name="TextBox 3"/>
+              <a:t>May Financial Performance Analysis</a:t>
+            </a:r>
+          </a:p>
+        </p:txBody>
+      </p:sp>
+      <p:sp>
+        <p:nvSpPr>
+          <p:cNvPr id="6" name="TextBox 5"/>
           <p:cNvSpPr txBox="1"/>
           <p:nvPr/>
         </p:nvSpPr>
         <p:spPr>
           <a:xfrm>
-            <a:off x="640080" y="4206240"/>
-            <a:ext cx="10881360" cy="457200"/>
+            <a:off x="777240" y="5029200"/>
+            <a:ext cx="10698480" cy="548640"/>
           </a:xfrm>
           <a:prstGeom prst="rect">
             <a:avLst/>
@@ -3183,13 +3271,13 @@
           <a:lstStyle/>
           <a:p>
             <a:r>
-              <a:rPr sz="1100" b="0">
-                <a:solidFill>
-                  <a:srgbClr val="7A828C"/>
+              <a:rPr sz="1700" b="0">
+                <a:solidFill>
+                  <a:srgbClr val="C0C5C9"/>
                 </a:solidFill>
                 <a:latin typeface="Calibri"/>
               </a:rPr>
-              <a:t>Generated 2026-06-10 17:37 UTC   |   CONFIDENTIAL</a:t>
+              <a:t>Finance / FP&amp;A dataset  ·  144 rows</a:t>
             </a:r>
           </a:p>
         </p:txBody>
@@ -3883,8 +3971,8 @@
         </p:blipFill>
         <p:spPr>
           <a:xfrm>
-            <a:off x="457200" y="1783080"/>
-            <a:ext cx="6949440" cy="3563815"/>
+            <a:off x="3264408" y="1645920"/>
+            <a:ext cx="5669280" cy="2907323"/>
           </a:xfrm>
           <a:prstGeom prst="rect">
             <a:avLst/>
@@ -3899,8 +3987,8 @@
         </p:nvSpPr>
         <p:spPr>
           <a:xfrm>
-            <a:off x="457200" y="5486400"/>
-            <a:ext cx="6949440" cy="868680"/>
+            <a:off x="457200" y="4572000"/>
+            <a:ext cx="11277295" cy="411480"/>
           </a:xfrm>
           <a:prstGeom prst="rect">
             <a:avLst/>
@@ -3913,14 +4001,15 @@
           </a:bodyPr>
           <a:lstStyle/>
           <a:p>
-            <a:r>
-              <a:rPr sz="1100" b="0">
-                <a:solidFill>
-                  <a:srgbClr val="7A828C"/>
+            <a:pPr algn="ctr"/>
+            <a:r>
+              <a:rPr sz="1300" b="1">
+                <a:solidFill>
+                  <a:srgbClr val="0C2E27"/>
                 </a:solidFill>
                 <a:latin typeface="Calibri"/>
               </a:rPr>
-              <a:t>In May 2026, Operations is the leading department with an actual total of $101k, despite experiencing a decline of -$8k compared to April 2026. Sales follows closely with $147k, while Marketing shows a positive trend with an increase of +$2k, reaching $75k. The overall concentration of spending highlights a significant focus on Sales and Operations, which together account for a substantial portion of the total departmental spend.</a:t>
+              <a:t>The decline in Operations spending signals potential operational challenges that need addressing.</a:t>
             </a:r>
           </a:p>
         </p:txBody>
@@ -3933,14 +4022,14 @@
         </p:nvSpPr>
         <p:spPr>
           <a:xfrm>
-            <a:off x="7772400" y="1783080"/>
-            <a:ext cx="3931920" cy="457200"/>
+            <a:off x="457200" y="5074920"/>
+            <a:ext cx="3454298" cy="50800"/>
           </a:xfrm>
           <a:prstGeom prst="rect">
             <a:avLst/>
           </a:prstGeom>
           <a:solidFill>
-            <a:srgbClr val="0C2E27"/>
+            <a:srgbClr val="0E7C66"/>
           </a:solidFill>
           <a:ln>
             <a:noFill/>
@@ -3962,43 +4051,100 @@
           </a:fontRef>
         </p:style>
         <p:txBody>
-          <a:bodyPr rtlCol="0" anchor="ctr" lIns="201168" tIns="18288" bIns="18288"/>
+          <a:bodyPr rtlCol="0" anchor="ctr"/>
           <a:lstStyle/>
           <a:p>
             <a:pPr algn="ctr"/>
-            <a:r>
-              <a:rPr sz="1200" b="1">
-                <a:solidFill>
-                  <a:srgbClr val="FFFFFF"/>
+          </a:p>
+        </p:txBody>
+      </p:sp>
+      <p:sp>
+        <p:nvSpPr>
+          <p:cNvPr id="8" name="TextBox 7"/>
+          <p:cNvSpPr txBox="1"/>
+          <p:nvPr/>
+        </p:nvSpPr>
+        <p:spPr>
+          <a:xfrm>
+            <a:off x="457200" y="5184648"/>
+            <a:ext cx="3454298" cy="777240"/>
+          </a:xfrm>
+          <a:prstGeom prst="rect">
+            <a:avLst/>
+          </a:prstGeom>
+          <a:noFill/>
+        </p:spPr>
+        <p:txBody>
+          <a:bodyPr wrap="square">
+            <a:spAutoFit/>
+          </a:bodyPr>
+          <a:lstStyle/>
+          <a:p>
+            <a:r>
+              <a:rPr sz="3000" b="1">
+                <a:solidFill>
+                  <a:srgbClr val="0C2E27"/>
+                </a:solidFill>
+                <a:latin typeface="Cambria"/>
+              </a:rPr>
+              <a:t>$147k</a:t>
+            </a:r>
+          </a:p>
+        </p:txBody>
+      </p:sp>
+      <p:sp>
+        <p:nvSpPr>
+          <p:cNvPr id="9" name="TextBox 8"/>
+          <p:cNvSpPr txBox="1"/>
+          <p:nvPr/>
+        </p:nvSpPr>
+        <p:spPr>
+          <a:xfrm>
+            <a:off x="457200" y="5943600"/>
+            <a:ext cx="3454298" cy="502920"/>
+          </a:xfrm>
+          <a:prstGeom prst="rect">
+            <a:avLst/>
+          </a:prstGeom>
+          <a:noFill/>
+        </p:spPr>
+        <p:txBody>
+          <a:bodyPr wrap="square">
+            <a:spAutoFit/>
+          </a:bodyPr>
+          <a:lstStyle/>
+          <a:p>
+            <a:r>
+              <a:rPr sz="1200" b="0">
+                <a:solidFill>
+                  <a:srgbClr val="7A828C"/>
                 </a:solidFill>
                 <a:latin typeface="Calibri"/>
               </a:rPr>
-              <a:t>KEY TAKEAWAY</a:t>
-            </a:r>
-          </a:p>
-        </p:txBody>
-      </p:sp>
-      <p:sp>
-        <p:nvSpPr>
-          <p:cNvPr id="8" name="Rectangle 7"/>
+              <a:t>Sales</a:t>
+            </a:r>
+          </a:p>
+        </p:txBody>
+      </p:sp>
+      <p:sp>
+        <p:nvSpPr>
+          <p:cNvPr id="10" name="Rectangle 9"/>
           <p:cNvSpPr/>
           <p:nvPr/>
         </p:nvSpPr>
         <p:spPr>
           <a:xfrm>
-            <a:off x="7772400" y="2240280"/>
-            <a:ext cx="3931920" cy="3200400"/>
+            <a:off x="4368698" y="5074920"/>
+            <a:ext cx="3454298" cy="50800"/>
           </a:xfrm>
           <a:prstGeom prst="rect">
             <a:avLst/>
           </a:prstGeom>
           <a:solidFill>
-            <a:srgbClr val="E6E8EB"/>
+            <a:srgbClr val="0E7C66"/>
           </a:solidFill>
-          <a:ln w="9525">
-            <a:solidFill>
-              <a:srgbClr val="C0C5C9"/>
-            </a:solidFill>
+          <a:ln>
+            <a:noFill/>
           </a:ln>
           <a:effectLst/>
         </p:spPr>
@@ -4017,70 +4163,189 @@
           </a:fontRef>
         </p:style>
         <p:txBody>
-          <a:bodyPr rtlCol="0" anchor="t" wrap="square" lIns="219456" rIns="219456" tIns="237744"/>
-          <a:lstStyle/>
-          <a:p>
-            <a:pPr algn="l">
-              <a:spcAft>
-                <a:spcPts val="1600"/>
-              </a:spcAft>
-            </a:pPr>
-            <a:r>
-              <a:rPr sz="1300" b="0">
-                <a:solidFill>
-                  <a:srgbClr val="3C4450"/>
+          <a:bodyPr rtlCol="0" anchor="ctr"/>
+          <a:lstStyle/>
+          <a:p>
+            <a:pPr algn="ctr"/>
+          </a:p>
+        </p:txBody>
+      </p:sp>
+      <p:sp>
+        <p:nvSpPr>
+          <p:cNvPr id="11" name="TextBox 10"/>
+          <p:cNvSpPr txBox="1"/>
+          <p:nvPr/>
+        </p:nvSpPr>
+        <p:spPr>
+          <a:xfrm>
+            <a:off x="4368698" y="5184648"/>
+            <a:ext cx="3454298" cy="777240"/>
+          </a:xfrm>
+          <a:prstGeom prst="rect">
+            <a:avLst/>
+          </a:prstGeom>
+          <a:noFill/>
+        </p:spPr>
+        <p:txBody>
+          <a:bodyPr wrap="square">
+            <a:spAutoFit/>
+          </a:bodyPr>
+          <a:lstStyle/>
+          <a:p>
+            <a:r>
+              <a:rPr sz="3000" b="1">
+                <a:solidFill>
+                  <a:srgbClr val="0C2E27"/>
+                </a:solidFill>
+                <a:latin typeface="Cambria"/>
+              </a:rPr>
+              <a:t>$101k</a:t>
+            </a:r>
+          </a:p>
+        </p:txBody>
+      </p:sp>
+      <p:sp>
+        <p:nvSpPr>
+          <p:cNvPr id="12" name="TextBox 11"/>
+          <p:cNvSpPr txBox="1"/>
+          <p:nvPr/>
+        </p:nvSpPr>
+        <p:spPr>
+          <a:xfrm>
+            <a:off x="4368698" y="5943600"/>
+            <a:ext cx="3454298" cy="502920"/>
+          </a:xfrm>
+          <a:prstGeom prst="rect">
+            <a:avLst/>
+          </a:prstGeom>
+          <a:noFill/>
+        </p:spPr>
+        <p:txBody>
+          <a:bodyPr wrap="square">
+            <a:spAutoFit/>
+          </a:bodyPr>
+          <a:lstStyle/>
+          <a:p>
+            <a:r>
+              <a:rPr sz="1200" b="0">
+                <a:solidFill>
+                  <a:srgbClr val="7A828C"/>
                 </a:solidFill>
                 <a:latin typeface="Calibri"/>
               </a:rPr>
-              <a:t>The decline in Operations spending signals potential operational challenges that need addressing.</a:t>
-            </a:r>
-          </a:p>
-          <a:p>
-            <a:pPr algn="l">
-              <a:spcAft>
-                <a:spcPts val="700"/>
-              </a:spcAft>
-            </a:pPr>
-            <a:r>
-              <a:rPr sz="1100" b="0">
-                <a:solidFill>
-                  <a:srgbClr val="3C4450"/>
+              <a:t>Operations</a:t>
+            </a:r>
+          </a:p>
+        </p:txBody>
+      </p:sp>
+      <p:sp>
+        <p:nvSpPr>
+          <p:cNvPr id="13" name="Rectangle 12"/>
+          <p:cNvSpPr/>
+          <p:nvPr/>
+        </p:nvSpPr>
+        <p:spPr>
+          <a:xfrm>
+            <a:off x="8280196" y="5074920"/>
+            <a:ext cx="3454298" cy="50800"/>
+          </a:xfrm>
+          <a:prstGeom prst="rect">
+            <a:avLst/>
+          </a:prstGeom>
+          <a:solidFill>
+            <a:srgbClr val="0E7C66"/>
+          </a:solidFill>
+          <a:ln>
+            <a:noFill/>
+          </a:ln>
+          <a:effectLst/>
+        </p:spPr>
+        <p:style>
+          <a:lnRef idx="1">
+            <a:schemeClr val="accent1"/>
+          </a:lnRef>
+          <a:fillRef idx="3">
+            <a:schemeClr val="accent1"/>
+          </a:fillRef>
+          <a:effectRef idx="2">
+            <a:schemeClr val="accent1"/>
+          </a:effectRef>
+          <a:fontRef idx="minor">
+            <a:schemeClr val="lt1"/>
+          </a:fontRef>
+        </p:style>
+        <p:txBody>
+          <a:bodyPr rtlCol="0" anchor="ctr"/>
+          <a:lstStyle/>
+          <a:p>
+            <a:pPr algn="ctr"/>
+          </a:p>
+        </p:txBody>
+      </p:sp>
+      <p:sp>
+        <p:nvSpPr>
+          <p:cNvPr id="14" name="TextBox 13"/>
+          <p:cNvSpPr txBox="1"/>
+          <p:nvPr/>
+        </p:nvSpPr>
+        <p:spPr>
+          <a:xfrm>
+            <a:off x="8280196" y="5184648"/>
+            <a:ext cx="3454298" cy="777240"/>
+          </a:xfrm>
+          <a:prstGeom prst="rect">
+            <a:avLst/>
+          </a:prstGeom>
+          <a:noFill/>
+        </p:spPr>
+        <p:txBody>
+          <a:bodyPr wrap="square">
+            <a:spAutoFit/>
+          </a:bodyPr>
+          <a:lstStyle/>
+          <a:p>
+            <a:r>
+              <a:rPr sz="3000" b="1">
+                <a:solidFill>
+                  <a:srgbClr val="0C2E27"/>
+                </a:solidFill>
+                <a:latin typeface="Cambria"/>
+              </a:rPr>
+              <a:t>$79k</a:t>
+            </a:r>
+          </a:p>
+        </p:txBody>
+      </p:sp>
+      <p:sp>
+        <p:nvSpPr>
+          <p:cNvPr id="15" name="TextBox 14"/>
+          <p:cNvSpPr txBox="1"/>
+          <p:nvPr/>
+        </p:nvSpPr>
+        <p:spPr>
+          <a:xfrm>
+            <a:off x="8280196" y="5943600"/>
+            <a:ext cx="3454298" cy="502920"/>
+          </a:xfrm>
+          <a:prstGeom prst="rect">
+            <a:avLst/>
+          </a:prstGeom>
+          <a:noFill/>
+        </p:spPr>
+        <p:txBody>
+          <a:bodyPr wrap="square">
+            <a:spAutoFit/>
+          </a:bodyPr>
+          <a:lstStyle/>
+          <a:p>
+            <a:r>
+              <a:rPr sz="1200" b="0">
+                <a:solidFill>
+                  <a:srgbClr val="7A828C"/>
                 </a:solidFill>
                 <a:latin typeface="Calibri"/>
               </a:rPr>
-              <a:t>•  Sales at $147k remains the highest department spend.</a:t>
-            </a:r>
-          </a:p>
-          <a:p>
-            <a:pPr algn="l">
-              <a:spcAft>
-                <a:spcPts val="700"/>
-              </a:spcAft>
-            </a:pPr>
-            <a:r>
-              <a:rPr sz="1100" b="0">
-                <a:solidFill>
-                  <a:srgbClr val="3C4450"/>
-                </a:solidFill>
-                <a:latin typeface="Calibri"/>
-              </a:rPr>
-              <a:t>•  Operations saw the largest decrease of -$8k this month.</a:t>
-            </a:r>
-          </a:p>
-          <a:p>
-            <a:pPr algn="l">
-              <a:spcAft>
-                <a:spcPts val="700"/>
-              </a:spcAft>
-            </a:pPr>
-            <a:r>
-              <a:rPr sz="1100" b="0">
-                <a:solidFill>
-                  <a:srgbClr val="3C4450"/>
-                </a:solidFill>
-                <a:latin typeface="Calibri"/>
-              </a:rPr>
-              <a:t>•  Marketing is the only department with a positive change, increasing by +$2k.</a:t>
+              <a:t>R&amp;D</a:t>
             </a:r>
           </a:p>
         </p:txBody>

</xml_diff>

<commit_message>
polish: vertically-centred cover title, no rule; remove em-dashes from visible text
Cover: title (with subtitle) vertically centred, no accent rule. Removed em-dashes from the chat illustration, KPI slide descriptions and the privacy page (AI-generated report prose already strips them via _no_dashes).

Co-Authored-By: Claude Fable 5 <noreply@anthropic.com>
</commit_message>
<xml_diff>
--- a/app/examples/fpa_budget/report.pptx
+++ b/app/examples/fpa_budget/report.pptx
@@ -3101,8 +3101,8 @@
         </p:nvSpPr>
         <p:spPr>
           <a:xfrm>
-            <a:off x="777240" y="777240"/>
-            <a:ext cx="10607040" cy="1828800"/>
+            <a:off x="777240" y="914400"/>
+            <a:ext cx="10607040" cy="5029200"/>
           </a:xfrm>
           <a:prstGeom prst="rect">
             <a:avLst/>
@@ -3110,11 +3110,16 @@
           <a:noFill/>
         </p:spPr>
         <p:txBody>
-          <a:bodyPr wrap="square">
+          <a:bodyPr wrap="square" anchor="ctr">
             <a:spAutoFit/>
           </a:bodyPr>
           <a:lstStyle/>
           <a:p>
+            <a:pPr>
+              <a:spcAft>
+                <a:spcPts val="1400"/>
+              </a:spcAft>
+            </a:pPr>
             <a:r>
               <a:rPr sz="4600" b="1">
                 <a:solidFill>
@@ -3125,73 +3130,6 @@
               <a:t>May Financial Performance Overview</a:t>
             </a:r>
           </a:p>
-        </p:txBody>
-      </p:sp>
-      <p:sp>
-        <p:nvSpPr>
-          <p:cNvPr id="3" name="Rectangle 2"/>
-          <p:cNvSpPr/>
-          <p:nvPr/>
-        </p:nvSpPr>
-        <p:spPr>
-          <a:xfrm>
-            <a:off x="822960" y="2743200"/>
-            <a:ext cx="1554480" cy="76200"/>
-          </a:xfrm>
-          <a:prstGeom prst="rect">
-            <a:avLst/>
-          </a:prstGeom>
-          <a:solidFill>
-            <a:srgbClr val="0E7C66"/>
-          </a:solidFill>
-          <a:ln>
-            <a:noFill/>
-          </a:ln>
-          <a:effectLst/>
-        </p:spPr>
-        <p:style>
-          <a:lnRef idx="1">
-            <a:schemeClr val="accent1"/>
-          </a:lnRef>
-          <a:fillRef idx="3">
-            <a:schemeClr val="accent1"/>
-          </a:fillRef>
-          <a:effectRef idx="2">
-            <a:schemeClr val="accent1"/>
-          </a:effectRef>
-          <a:fontRef idx="minor">
-            <a:schemeClr val="lt1"/>
-          </a:fontRef>
-        </p:style>
-        <p:txBody>
-          <a:bodyPr rtlCol="0" anchor="ctr"/>
-          <a:lstStyle/>
-          <a:p>
-            <a:pPr algn="ctr"/>
-          </a:p>
-        </p:txBody>
-      </p:sp>
-      <p:sp>
-        <p:nvSpPr>
-          <p:cNvPr id="4" name="TextBox 3"/>
-          <p:cNvSpPr txBox="1"/>
-          <p:nvPr/>
-        </p:nvSpPr>
-        <p:spPr>
-          <a:xfrm>
-            <a:off x="777240" y="2971800"/>
-            <a:ext cx="10607040" cy="548640"/>
-          </a:xfrm>
-          <a:prstGeom prst="rect">
-            <a:avLst/>
-          </a:prstGeom>
-          <a:noFill/>
-        </p:spPr>
-        <p:txBody>
-          <a:bodyPr wrap="square">
-            <a:spAutoFit/>
-          </a:bodyPr>
-          <a:lstStyle/>
           <a:p>
             <a:r>
               <a:rPr sz="1700" b="0">

</xml_diff>